<commit_message>
Add Level-Up bonus slides to K2 M02-M08 PPTs
</commit_message>
<xml_diff>
--- a/K2-Produktivitas/M02-Claude-Projects/K2-M02-Claude-Projects.pptx
+++ b/K2-Produktivitas/M02-Claude-Projects/K2-M02-Claude-Projects.pptx
@@ -9,9 +9,10 @@
     <p:sldId id="257" r:id="rId3"/>
     <p:sldId id="258" r:id="rId4"/>
     <p:sldId id="259" r:id="rId5"/>
+    <p:sldId id="260" r:id="rId6"/>
   </p:sldIdLst>
   <p:notesMasterIdLst>
-    <p:notesMasterId r:id="rId6"/>
+    <p:notesMasterId r:id="rId7"/>
   </p:notesMasterIdLst>
   <p:sldSz cx="12191695" cy="6858000"/>
   <p:notesSz cx="6858000" cy="12191695"/>
@@ -811,6 +812,94 @@
 </p:notes>
 </file>
 
+<file path=ppt/notesSlides/notesSlide5.xml><?xml version="1.0" encoding="utf-8"?>
+<p:notes xmlns:a="http://schemas.openxmlformats.org/drawingml/2006/main" xmlns:r="http://schemas.openxmlformats.org/officeDocument/2006/relationships" xmlns:p="http://schemas.openxmlformats.org/presentationml/2006/main">
+  <p:cSld>
+    <p:spTree>
+      <p:nvGrpSpPr>
+        <p:cNvPr id="1" name=""/>
+        <p:cNvGrpSpPr/>
+        <p:nvPr/>
+      </p:nvGrpSpPr>
+      <p:grpSpPr>
+        <a:xfrm>
+          <a:off x="0" y="0"/>
+          <a:ext cx="0" cy="0"/>
+          <a:chOff x="0" y="0"/>
+          <a:chExt cx="0" cy="0"/>
+        </a:xfrm>
+      </p:grpSpPr>
+      <p:sp>
+        <p:nvSpPr>
+          <p:cNvPr id="2" name="Slide Image Placeholder 1"/>
+          <p:cNvSpPr>
+            <a:spLocks noGrp="1" noRot="1" noChangeAspect="1"/>
+          </p:cNvSpPr>
+          <p:nvPr>
+            <p:ph type="sldImg"/>
+          </p:nvPr>
+        </p:nvSpPr>
+        <p:spPr/>
+      </p:sp>
+      <p:sp>
+        <p:nvSpPr>
+          <p:cNvPr id="3" name="Notes Placeholder 2"/>
+          <p:cNvSpPr>
+            <a:spLocks noGrp="1"/>
+          </p:cNvSpPr>
+          <p:nvPr>
+            <p:ph type="body" idx="1"/>
+          </p:nvPr>
+        </p:nvSpPr>
+        <p:spPr/>
+        <p:txBody>
+          <a:bodyPr/>
+          <a:lstStyle/>
+          <a:p>
+            <a:r>
+              <a:rPr lang="en-US" dirty="0"/>
+              <a:t/>
+            </a:r>
+            <a:endParaRPr lang="en-US" dirty="0"/>
+          </a:p>
+        </p:txBody>
+      </p:sp>
+      <p:sp>
+        <p:nvSpPr>
+          <p:cNvPr id="4" name="Slide Number Placeholder 3"/>
+          <p:cNvSpPr>
+            <a:spLocks noGrp="1"/>
+          </p:cNvSpPr>
+          <p:nvPr>
+            <p:ph type="sldNum" sz="quarter" idx="10"/>
+          </p:nvPr>
+        </p:nvSpPr>
+        <p:spPr/>
+        <p:txBody>
+          <a:bodyPr/>
+          <a:lstStyle/>
+          <a:p>
+            <a:fld id="{F7021451-1387-4CA6-816F-3879F97B5CBC}" type="slidenum">
+              <a:rPr lang="en-US"/>
+              <a:t>5</a:t>
+            </a:fld>
+            <a:endParaRPr lang="en-US"/>
+          </a:p>
+        </p:txBody>
+      </p:sp>
+    </p:spTree>
+    <p:extLst>
+      <p:ext uri="{BB962C8B-B14F-4D97-AF65-F5344CB8AC3E}">
+        <p14:creationId xmlns:p14="http://schemas.microsoft.com/office/powerpoint/2010/main" val="1024086991"/>
+      </p:ext>
+    </p:extLst>
+  </p:cSld>
+  <p:clrMapOvr>
+    <a:masterClrMapping/>
+  </p:clrMapOvr>
+</p:notes>
+</file>
+
 <file path=ppt/slideLayouts/slideLayout1.xml><?xml version="1.0" encoding="utf-8"?>
 <p:sldLayout xmlns:a="http://schemas.openxmlformats.org/drawingml/2006/main" xmlns:r="http://schemas.openxmlformats.org/officeDocument/2006/relationships" xmlns:p="http://schemas.openxmlformats.org/presentationml/2006/main" preserve="1">
   <p:cSld name="DEFAULT">
@@ -3979,6 +4068,356 @@
                 <a:cs typeface="Helvetica" pitchFamily="34" charset="-120"/>
               </a:rPr>
               <a:t>Setup Claude Project pertamamu sekarang: (1) Buka Claude → klik "New Project" → beri nama sesuai bisnismu, (2) Salin template System Instructions dari slide sebelumnya, (3) Isi dengan info bisnismu sendiri, (4) Test dengan 3 prompt berbeda. Output: 1 Project aktif dengan System Instructions terisi.</a:t>
+            </a:r>
+            <a:endParaRPr lang="en-US" sz="1250" dirty="0"/>
+          </a:p>
+        </p:txBody>
+      </p:sp>
+    </p:spTree>
+  </p:cSld>
+  <p:clrMapOvr>
+    <a:masterClrMapping/>
+  </p:clrMapOvr>
+</p:sld>
+</file>
+
+<file path=ppt/slides/slide5.xml><?xml version="1.0" encoding="utf-8"?>
+<p:sld xmlns:a="http://schemas.openxmlformats.org/drawingml/2006/main" xmlns:r="http://schemas.openxmlformats.org/officeDocument/2006/relationships" xmlns:p="http://schemas.openxmlformats.org/presentationml/2006/main">
+  <p:cSld name="Slide 5">
+    <p:bg>
+      <p:bgPr>
+        <a:solidFill>
+          <a:srgbClr val="FFFFFF"/>
+        </a:solidFill>
+      </p:bgPr>
+    </p:bg>
+    <p:spTree>
+      <p:nvGrpSpPr>
+        <p:cNvPr id="1" name=""/>
+        <p:cNvGrpSpPr/>
+        <p:nvPr/>
+      </p:nvGrpSpPr>
+      <p:grpSpPr>
+        <a:xfrm>
+          <a:off x="0" y="0"/>
+          <a:ext cx="0" cy="0"/>
+          <a:chOff x="0" y="0"/>
+          <a:chExt cx="0" cy="0"/>
+        </a:xfrm>
+      </p:grpSpPr>
+      <p:sp>
+        <p:nvSpPr>
+          <p:cNvPr id="2" name="Shape 0"/>
+          <p:cNvSpPr/>
+          <p:nvPr/>
+        </p:nvSpPr>
+        <p:spPr>
+          <a:xfrm>
+            <a:off x="0" y="0"/>
+            <a:ext cx="12191695" cy="960120"/>
+          </a:xfrm>
+          <a:prstGeom prst="rect">
+            <a:avLst/>
+          </a:prstGeom>
+          <a:solidFill>
+            <a:srgbClr val="0D1321"/>
+          </a:solidFill>
+          <a:ln/>
+        </p:spPr>
+      </p:sp>
+      <p:sp>
+        <p:nvSpPr>
+          <p:cNvPr id="3" name="Shape 1"/>
+          <p:cNvSpPr/>
+          <p:nvPr/>
+        </p:nvSpPr>
+        <p:spPr>
+          <a:xfrm>
+            <a:off x="0" y="960120"/>
+            <a:ext cx="12191695" cy="41148"/>
+          </a:xfrm>
+          <a:prstGeom prst="rect">
+            <a:avLst/>
+          </a:prstGeom>
+          <a:solidFill>
+            <a:srgbClr val="6849F6"/>
+          </a:solidFill>
+          <a:ln/>
+        </p:spPr>
+      </p:sp>
+      <p:sp>
+        <p:nvSpPr>
+          <p:cNvPr id="4" name="Text 2"/>
+          <p:cNvSpPr/>
+          <p:nvPr/>
+        </p:nvSpPr>
+        <p:spPr>
+          <a:xfrm>
+            <a:off x="502920" y="256032"/>
+            <a:ext cx="3657600" cy="457200"/>
+          </a:xfrm>
+          <a:prstGeom prst="rect">
+            <a:avLst/>
+          </a:prstGeom>
+          <a:noFill/>
+          <a:ln/>
+        </p:spPr>
+        <p:txBody>
+          <a:bodyPr wrap="square" lIns="0" tIns="0" rIns="0" bIns="0" rtlCol="0" anchor="ctr"/>
+          <a:lstStyle/>
+          <a:p>
+            <a:pPr indent="0" marL="0">
+              <a:buNone/>
+            </a:pPr>
+            <a:r>
+              <a:rPr lang="en-US" sz="2000" b="1" dirty="0">
+                <a:solidFill>
+                  <a:srgbClr val="FFFFFF"/>
+                </a:solidFill>
+                <a:latin typeface="Helvetica" pitchFamily="34" charset="0"/>
+                <a:ea typeface="Helvetica" pitchFamily="34" charset="-122"/>
+                <a:cs typeface="Helvetica" pitchFamily="34" charset="-120"/>
+              </a:rPr>
+              <a:t>belajar</a:t>
+            </a:r>
+            <a:pPr indent="0" marL="0">
+              <a:buNone/>
+            </a:pPr>
+            <a:r>
+              <a:rPr lang="en-US" sz="2000" b="1" dirty="0">
+                <a:solidFill>
+                  <a:srgbClr val="8B7CF6"/>
+                </a:solidFill>
+                <a:latin typeface="Helvetica" pitchFamily="34" charset="0"/>
+                <a:ea typeface="Helvetica" pitchFamily="34" charset="-122"/>
+                <a:cs typeface="Helvetica" pitchFamily="34" charset="-120"/>
+              </a:rPr>
+              <a:t>claude</a:t>
+            </a:r>
+            <a:endParaRPr lang="en-US" sz="2000" dirty="0"/>
+          </a:p>
+        </p:txBody>
+      </p:sp>
+      <p:sp>
+        <p:nvSpPr>
+          <p:cNvPr id="5" name="Text 3"/>
+          <p:cNvSpPr/>
+          <p:nvPr/>
+        </p:nvSpPr>
+        <p:spPr>
+          <a:xfrm>
+            <a:off x="5943600" y="274320"/>
+            <a:ext cx="5760720" cy="411480"/>
+          </a:xfrm>
+          <a:prstGeom prst="rect">
+            <a:avLst/>
+          </a:prstGeom>
+          <a:noFill/>
+          <a:ln/>
+        </p:spPr>
+        <p:txBody>
+          <a:bodyPr wrap="square" lIns="0" tIns="0" rIns="0" bIns="0" rtlCol="0" anchor="ctr"/>
+          <a:lstStyle/>
+          <a:p>
+            <a:pPr algn="r" indent="0" marL="0">
+              <a:buNone/>
+            </a:pPr>
+            <a:r>
+              <a:rPr lang="en-US" sz="1250" dirty="0">
+                <a:solidFill>
+                  <a:srgbClr val="9AA2B4"/>
+                </a:solidFill>
+                <a:latin typeface="Helvetica" pitchFamily="34" charset="0"/>
+                <a:ea typeface="Helvetica" pitchFamily="34" charset="-122"/>
+                <a:cs typeface="Helvetica" pitchFamily="34" charset="-120"/>
+              </a:rPr>
+              <a:t>Modul 02 — Claude Projects</a:t>
+            </a:r>
+            <a:endParaRPr lang="en-US" sz="1250" dirty="0"/>
+          </a:p>
+        </p:txBody>
+      </p:sp>
+      <p:sp>
+        <p:nvSpPr>
+          <p:cNvPr id="6" name="Text 4"/>
+          <p:cNvSpPr/>
+          <p:nvPr/>
+        </p:nvSpPr>
+        <p:spPr>
+          <a:xfrm>
+            <a:off x="548640" y="1188720"/>
+            <a:ext cx="11064240" cy="502920"/>
+          </a:xfrm>
+          <a:prstGeom prst="rect">
+            <a:avLst/>
+          </a:prstGeom>
+          <a:noFill/>
+          <a:ln/>
+        </p:spPr>
+        <p:txBody>
+          <a:bodyPr wrap="square" lIns="0" tIns="0" rIns="0" bIns="0" rtlCol="0" anchor="ctr"/>
+          <a:lstStyle/>
+          <a:p>
+            <a:pPr indent="0" marL="0">
+              <a:buNone/>
+            </a:pPr>
+            <a:r>
+              <a:rPr lang="en-US" sz="2200" b="1" dirty="0">
+                <a:solidFill>
+                  <a:srgbClr val="0D1321"/>
+                </a:solidFill>
+                <a:latin typeface="Helvetica" pitchFamily="34" charset="0"/>
+                <a:ea typeface="Helvetica" pitchFamily="34" charset="-122"/>
+                <a:cs typeface="Helvetica" pitchFamily="34" charset="-120"/>
+              </a:rPr>
+              <a:t>Bonus: Referensi Project Lengkap</a:t>
+            </a:r>
+            <a:endParaRPr lang="en-US" sz="2200" dirty="0"/>
+          </a:p>
+        </p:txBody>
+      </p:sp>
+      <p:sp>
+        <p:nvSpPr>
+          <p:cNvPr id="7" name="Text 5"/>
+          <p:cNvSpPr/>
+          <p:nvPr/>
+        </p:nvSpPr>
+        <p:spPr>
+          <a:xfrm>
+            <a:off x="548640" y="1783080"/>
+            <a:ext cx="11094415" cy="274320"/>
+          </a:xfrm>
+          <a:prstGeom prst="rect">
+            <a:avLst/>
+          </a:prstGeom>
+          <a:noFill/>
+          <a:ln/>
+        </p:spPr>
+        <p:txBody>
+          <a:bodyPr wrap="square" lIns="0" tIns="0" rIns="0" bIns="0" rtlCol="0" anchor="ctr"/>
+          <a:lstStyle/>
+          <a:p>
+            <a:pPr indent="0" marL="0">
+              <a:buNone/>
+            </a:pPr>
+            <a:r>
+              <a:rPr lang="en-US" sz="1250" b="1" spc="40" kern="0" dirty="0">
+                <a:solidFill>
+                  <a:srgbClr val="4B36C7"/>
+                </a:solidFill>
+                <a:latin typeface="Helvetica" pitchFamily="34" charset="0"/>
+                <a:ea typeface="Helvetica" pitchFamily="34" charset="-122"/>
+                <a:cs typeface="Helvetica" pitchFamily="34" charset="-120"/>
+              </a:rPr>
+              <a:t>UNTUK YANG MAU CONTOH LEBIH DETAIL</a:t>
+            </a:r>
+            <a:endParaRPr lang="en-US" sz="1250" dirty="0"/>
+          </a:p>
+        </p:txBody>
+      </p:sp>
+      <p:sp>
+        <p:nvSpPr>
+          <p:cNvPr id="8" name="Shape 6"/>
+          <p:cNvSpPr/>
+          <p:nvPr/>
+        </p:nvSpPr>
+        <p:spPr>
+          <a:xfrm>
+            <a:off x="548640" y="2112264"/>
+            <a:ext cx="11094415" cy="1480376"/>
+          </a:xfrm>
+          <a:prstGeom prst="roundRect">
+            <a:avLst>
+              <a:gd name="adj" fmla="val 6177"/>
+            </a:avLst>
+          </a:prstGeom>
+          <a:solidFill>
+            <a:srgbClr val="F3F0FF"/>
+          </a:solidFill>
+          <a:ln w="12700">
+            <a:solidFill>
+              <a:srgbClr val="DCD3FB"/>
+            </a:solidFill>
+            <a:prstDash val="solid"/>
+          </a:ln>
+        </p:spPr>
+      </p:sp>
+      <p:sp>
+        <p:nvSpPr>
+          <p:cNvPr id="9" name="Text 7"/>
+          <p:cNvSpPr/>
+          <p:nvPr/>
+        </p:nvSpPr>
+        <p:spPr>
+          <a:xfrm>
+            <a:off x="749808" y="2313432"/>
+            <a:ext cx="10692079" cy="274320"/>
+          </a:xfrm>
+          <a:prstGeom prst="rect">
+            <a:avLst/>
+          </a:prstGeom>
+          <a:noFill/>
+          <a:ln/>
+        </p:spPr>
+        <p:txBody>
+          <a:bodyPr wrap="square" lIns="0" tIns="0" rIns="0" bIns="0" rtlCol="0" anchor="ctr"/>
+          <a:lstStyle/>
+          <a:p>
+            <a:pPr indent="0" marL="0">
+              <a:buNone/>
+            </a:pPr>
+            <a:r>
+              <a:rPr lang="en-US" sz="1250" b="1" spc="30" kern="0" dirty="0">
+                <a:solidFill>
+                  <a:srgbClr val="4B36C7"/>
+                </a:solidFill>
+                <a:latin typeface="Helvetica" pitchFamily="34" charset="0"/>
+                <a:ea typeface="Helvetica" pitchFamily="34" charset="-122"/>
+                <a:cs typeface="Helvetica" pitchFamily="34" charset="-120"/>
+              </a:rPr>
+              <a:t>◆  DOWNLOAD K2-M2-REFERENSI-PROJECT.TXT</a:t>
+            </a:r>
+            <a:endParaRPr lang="en-US" sz="1250" dirty="0"/>
+          </a:p>
+        </p:txBody>
+      </p:sp>
+      <p:sp>
+        <p:nvSpPr>
+          <p:cNvPr id="10" name="Text 8"/>
+          <p:cNvSpPr/>
+          <p:nvPr/>
+        </p:nvSpPr>
+        <p:spPr>
+          <a:xfrm>
+            <a:off x="749808" y="2660904"/>
+            <a:ext cx="10692079" cy="730568"/>
+          </a:xfrm>
+          <a:prstGeom prst="rect">
+            <a:avLst/>
+          </a:prstGeom>
+          <a:noFill/>
+          <a:ln/>
+        </p:spPr>
+        <p:txBody>
+          <a:bodyPr wrap="square" lIns="0" tIns="0" rIns="0" bIns="0" rtlCol="0" anchor="t"/>
+          <a:lstStyle/>
+          <a:p>
+            <a:pPr indent="0" marL="0">
+              <a:lnSpc>
+                <a:spcPct val="130000"/>
+              </a:lnSpc>
+              <a:buNone/>
+            </a:pPr>
+            <a:r>
+              <a:rPr lang="en-US" sz="1250" dirty="0">
+                <a:solidFill>
+                  <a:srgbClr val="23283A"/>
+                </a:solidFill>
+                <a:latin typeface="Helvetica" pitchFamily="34" charset="0"/>
+                <a:ea typeface="Helvetica" pitchFamily="34" charset="-122"/>
+                <a:cs typeface="Helvetica" pitchFamily="34" charset="-120"/>
+              </a:rPr>
+              <a:t>Template di modul ini cukup untuk mulai. File referensi ini adalah contoh System Instructions penuh — profil bisnis, brand voice, format output standar, dan catatan khusus untuk Claude — untuk sebuah agensi digital marketing. Bisa dipakai sebagai kerangka, tinggal ganti isinya dengan data bisnismu sendiri.</a:t>
             </a:r>
             <a:endParaRPr lang="en-US" sz="1250" dirty="0"/>
           </a:p>

</xml_diff>

<commit_message>
M2: exercise now uses k2-m2-referensi-project.txt directly instead of requiring own business info first
</commit_message>
<xml_diff>
--- a/K2-Produktivitas/M02-Claude-Projects/K2-M02-Claude-Projects.pptx
+++ b/K2-Produktivitas/M02-Claude-Projects/K2-M02-Claude-Projects.pptx
@@ -2838,7 +2838,7 @@
                 <a:ea typeface="Helvetica" pitchFamily="34" charset="-122"/>
                 <a:cs typeface="Helvetica" pitchFamily="34" charset="-120"/>
               </a:rPr>
-              <a:t>Klik "New Project" di sidebar kiri Claude. Beri nama project sesuai bisnismu (contoh: "Kasual Studio").</a:t>
+              <a:t>Klik "New Project" di sidebar kiri Claude. Beri nama (contoh: "Latihan Modul 2").</a:t>
             </a:r>
             <a:endParaRPr lang="en-US" sz="1200" dirty="0"/>
           </a:p>
@@ -2963,7 +2963,7 @@
                 <a:ea typeface="Helvetica" pitchFamily="34" charset="-122"/>
                 <a:cs typeface="Helvetica" pitchFamily="34" charset="-120"/>
               </a:rPr>
-              <a:t>Isi Project Instructions</a:t>
+              <a:t>Pakai File Referensi</a:t>
             </a:r>
             <a:endParaRPr lang="en-US" sz="1400" dirty="0"/>
           </a:p>
@@ -3005,7 +3005,7 @@
                 <a:ea typeface="Helvetica" pitchFamily="34" charset="-122"/>
                 <a:cs typeface="Helvetica" pitchFamily="34" charset="-120"/>
               </a:rPr>
-              <a:t>Tulis System Instructions — konteks bisnis, tone, dan format yang Claude baca di setiap sesi dalam project ini.</a:t>
+              <a:t>Download k2-m2-referensi-project.txt dari halaman materi, paste seluruh isinya sebagai Project Instructions.</a:t>
             </a:r>
             <a:endParaRPr lang="en-US" sz="1200" dirty="0"/>
           </a:p>
@@ -3172,7 +3172,7 @@
                 <a:ea typeface="Helvetica" pitchFamily="34" charset="-122"/>
                 <a:cs typeface="Helvetica" pitchFamily="34" charset="-120"/>
               </a:rPr>
-              <a:t>Buka chat di dalam project. Tidak perlu briefing ulang — Claude langsung tahu konteks bisnismu.</a:t>
+              <a:t>Buka chat di dalam project. Tidak perlu briefing ulang — Claude langsung tahu konteks PT Kreatif Digital.</a:t>
             </a:r>
             <a:endParaRPr lang="en-US" sz="1200" dirty="0"/>
           </a:p>
@@ -3974,11 +3974,11 @@
         <p:spPr>
           <a:xfrm>
             <a:off x="548640" y="3828136"/>
-            <a:ext cx="11094415" cy="1480376"/>
+            <a:ext cx="11094415" cy="1723898"/>
           </a:xfrm>
           <a:prstGeom prst="roundRect">
             <a:avLst>
-              <a:gd name="adj" fmla="val 6177"/>
+              <a:gd name="adj" fmla="val 5304"/>
             </a:avLst>
           </a:prstGeom>
           <a:solidFill>
@@ -4040,7 +4040,7 @@
         <p:spPr>
           <a:xfrm>
             <a:off x="749808" y="4376776"/>
-            <a:ext cx="10692079" cy="730568"/>
+            <a:ext cx="10692079" cy="974090"/>
           </a:xfrm>
           <a:prstGeom prst="rect">
             <a:avLst/>
@@ -4067,7 +4067,7 @@
                 <a:ea typeface="Helvetica" pitchFamily="34" charset="-122"/>
                 <a:cs typeface="Helvetica" pitchFamily="34" charset="-120"/>
               </a:rPr>
-              <a:t>Setup Claude Project pertamamu sekarang: (1) Buka Claude → klik "New Project" → beri nama sesuai bisnismu, (2) Salin template System Instructions dari slide sebelumnya, (3) Isi dengan info bisnismu sendiri, (4) Test dengan 3 prompt berbeda. Output: 1 Project aktif dengan System Instructions terisi.</a:t>
+              <a:t>Setup Claude Project pertamamu pakai k2-m2-referensi-project.txt: (1) Buka Claude → "New Project" → beri nama, (2) Download file dari halaman materi, paste sebagai Project Instructions, (3) Test 3 prompt pendek — "tulis caption promo diskon 20%", "balas email klien komplain laporan terlalu teknis", "buatkan 3 poin highlight laporan bulanan". Output: Claude merespons sesuai konteks PT Kreatif Digital tanpa briefing ulang.</a:t>
             </a:r>
             <a:endParaRPr lang="en-US" sz="1250" dirty="0"/>
           </a:p>
@@ -4270,7 +4270,7 @@
                 <a:ea typeface="Helvetica" pitchFamily="34" charset="-122"/>
                 <a:cs typeface="Helvetica" pitchFamily="34" charset="-120"/>
               </a:rPr>
-              <a:t>Bonus: Referensi Project Lengkap</a:t>
+              <a:t>Selanjutnya: Bikin Versi Bisnismu Sendiri</a:t>
             </a:r>
             <a:endParaRPr lang="en-US" sz="2200" dirty="0"/>
           </a:p>
@@ -4309,7 +4309,7 @@
                 <a:ea typeface="Helvetica" pitchFamily="34" charset="-122"/>
                 <a:cs typeface="Helvetica" pitchFamily="34" charset="-120"/>
               </a:rPr>
-              <a:t>UNTUK YANG MAU CONTOH LEBIH DETAIL</a:t>
+              <a:t>SETELAH TERBIASA LEWAT LATIHAN DI ATAS</a:t>
             </a:r>
             <a:endParaRPr lang="en-US" sz="1250" dirty="0"/>
           </a:p>
@@ -4324,11 +4324,11 @@
         <p:spPr>
           <a:xfrm>
             <a:off x="548640" y="2112264"/>
-            <a:ext cx="11094415" cy="1480376"/>
+            <a:ext cx="11094415" cy="1236853"/>
           </a:xfrm>
           <a:prstGeom prst="roundRect">
             <a:avLst>
-              <a:gd name="adj" fmla="val 6177"/>
+              <a:gd name="adj" fmla="val 7393"/>
             </a:avLst>
           </a:prstGeom>
           <a:solidFill>
@@ -4375,7 +4375,7 @@
                 <a:ea typeface="Helvetica" pitchFamily="34" charset="-122"/>
                 <a:cs typeface="Helvetica" pitchFamily="34" charset="-120"/>
               </a:rPr>
-              <a:t>◆  DOWNLOAD K2-M2-REFERENSI-PROJECT.TXT</a:t>
+              <a:t>◆  GANTI KE DATA BISNISMU</a:t>
             </a:r>
             <a:endParaRPr lang="en-US" sz="1250" dirty="0"/>
           </a:p>
@@ -4390,7 +4390,7 @@
         <p:spPr>
           <a:xfrm>
             <a:off x="749808" y="2660904"/>
-            <a:ext cx="10692079" cy="730568"/>
+            <a:ext cx="10692079" cy="487045"/>
           </a:xfrm>
           <a:prstGeom prst="rect">
             <a:avLst/>
@@ -4417,7 +4417,7 @@
                 <a:ea typeface="Helvetica" pitchFamily="34" charset="-122"/>
                 <a:cs typeface="Helvetica" pitchFamily="34" charset="-120"/>
               </a:rPr>
-              <a:t>Template di modul ini cukup untuk mulai. File referensi ini adalah contoh System Instructions penuh — profil bisnis, brand voice, format output standar, dan catatan khusus untuk Claude — untuk sebuah agensi digital marketing. Bisa dipakai sebagai kerangka, tinggal ganti isinya dengan data bisnismu sendiri.</a:t>
+              <a:t>Setelah terbiasa lewat latihan k2-m2-referensi-project.txt, ganti isi Project Instructions dengan data bisnismu sendiri — pakai template System Instructions di slide 3 sebagai kerangka. Project ini yang akan kamu pakai terus di modul-modul berikutnya.</a:t>
             </a:r>
             <a:endParaRPr lang="en-US" sz="1250" dirty="0"/>
           </a:p>

</xml_diff>